<commit_message>
Update Android device name and package references in project files
</commit_message>
<xml_diff>
--- a/Doc/Appium - Notes.pptx
+++ b/Doc/Appium - Notes.pptx
@@ -5,10 +5,10 @@
     <p:sldMasterId id="2147483670" r:id="rId4"/>
   </p:sldMasterIdLst>
   <p:notesMasterIdLst>
-    <p:notesMasterId r:id="rId12"/>
+    <p:notesMasterId r:id="rId13"/>
   </p:notesMasterIdLst>
   <p:handoutMasterIdLst>
-    <p:handoutMasterId r:id="rId13"/>
+    <p:handoutMasterId r:id="rId14"/>
   </p:handoutMasterIdLst>
   <p:sldIdLst>
     <p:sldId id="256" r:id="rId5"/>
@@ -18,6 +18,7 @@
     <p:sldId id="260" r:id="rId9"/>
     <p:sldId id="261" r:id="rId10"/>
     <p:sldId id="262" r:id="rId11"/>
+    <p:sldId id="263" r:id="rId12"/>
   </p:sldIdLst>
   <p:sldSz cx="12192000" cy="6858000"/>
   <p:notesSz cx="6858000" cy="9144000"/>
@@ -224,7 +225,7 @@
           <a:p>
             <a:fld id="{56C2D11A-4A4C-4762-9A3D-38B816BFA086}" type="datetimeFigureOut">
               <a:rPr lang="fr-FR" smtClean="0"/>
-              <a:t>16/03/2026</a:t>
+              <a:t>01/05/2026</a:t>
             </a:fld>
             <a:endParaRPr lang="fr-FR"/>
           </a:p>
@@ -290,7 +291,7 @@
           <a:p>
             <a:fld id="{69029993-E93F-4628-BDE0-2946103AC1B3}" type="slidenum">
               <a:rPr lang="fr-FR" smtClean="0"/>
-              <a:t>‹N°›</a:t>
+              <a:t>‹#›</a:t>
             </a:fld>
             <a:endParaRPr lang="fr-FR"/>
           </a:p>
@@ -389,7 +390,7 @@
           <a:p>
             <a:fld id="{DD3E8838-E61C-436D-81FA-CFC9A861CF2C}" type="datetimeFigureOut">
               <a:rPr lang="fr-FR" noProof="0" smtClean="0"/>
-              <a:t>16/03/2026</a:t>
+              <a:t>01/05/2026</a:t>
             </a:fld>
             <a:endParaRPr lang="fr-FR" noProof="0"/>
           </a:p>
@@ -547,7 +548,7 @@
           <a:p>
             <a:fld id="{1DB0C060-F7D4-4C65-826A-795CA5BE88E2}" type="slidenum">
               <a:rPr lang="fr-FR" noProof="0" smtClean="0"/>
-              <a:t>‹N°›</a:t>
+              <a:t>‹#›</a:t>
             </a:fld>
             <a:endParaRPr lang="fr-FR" noProof="0"/>
           </a:p>
@@ -1531,6 +1532,1451 @@
 </p:notes>
 </file>
 
+<file path=ppt/notesSlides/notesSlide4.xml><?xml version="1.0" encoding="utf-8"?>
+<p:notes xmlns:a="http://schemas.openxmlformats.org/drawingml/2006/main" xmlns:r="http://schemas.openxmlformats.org/officeDocument/2006/relationships" xmlns:p="http://schemas.openxmlformats.org/presentationml/2006/main">
+  <p:cSld>
+    <p:spTree>
+      <p:nvGrpSpPr>
+        <p:cNvPr id="1" name=""/>
+        <p:cNvGrpSpPr/>
+        <p:nvPr/>
+      </p:nvGrpSpPr>
+      <p:grpSpPr>
+        <a:xfrm>
+          <a:off x="0" y="0"/>
+          <a:ext cx="0" cy="0"/>
+          <a:chOff x="0" y="0"/>
+          <a:chExt cx="0" cy="0"/>
+        </a:xfrm>
+      </p:grpSpPr>
+      <p:sp>
+        <p:nvSpPr>
+          <p:cNvPr id="2" name="Slide Image Placeholder 1"/>
+          <p:cNvSpPr>
+            <a:spLocks noGrp="1" noRot="1" noChangeAspect="1"/>
+          </p:cNvSpPr>
+          <p:nvPr>
+            <p:ph type="sldImg"/>
+          </p:nvPr>
+        </p:nvSpPr>
+        <p:spPr/>
+      </p:sp>
+      <p:sp>
+        <p:nvSpPr>
+          <p:cNvPr id="3" name="Notes Placeholder 2"/>
+          <p:cNvSpPr>
+            <a:spLocks noGrp="1"/>
+          </p:cNvSpPr>
+          <p:nvPr>
+            <p:ph type="body" idx="1"/>
+          </p:nvPr>
+        </p:nvSpPr>
+        <p:spPr/>
+        <p:txBody>
+          <a:bodyPr/>
+          <a:lstStyle/>
+          <a:p>
+            <a:r>
+              <a:rPr lang="en-GB" sz="1200" b="0" i="0" kern="1200" dirty="0">
+                <a:solidFill>
+                  <a:schemeClr val="tx1"/>
+                </a:solidFill>
+                <a:effectLst/>
+                <a:latin typeface="+mn-lt"/>
+                <a:ea typeface="+mn-ea"/>
+                <a:cs typeface="+mn-cs"/>
+              </a:rPr>
+              <a:t>Setting up Appium on macOS for iOS testing involves installing dependencies, configuring tools, and preparing the environment. Follow these steps to configure Appium effectively:</a:t>
+            </a:r>
+          </a:p>
+          <a:p>
+            <a:endParaRPr lang="en-GB" sz="1200" b="1" i="0" kern="1200" dirty="0">
+              <a:solidFill>
+                <a:schemeClr val="tx1"/>
+              </a:solidFill>
+              <a:effectLst/>
+              <a:latin typeface="+mn-lt"/>
+              <a:ea typeface="+mn-ea"/>
+              <a:cs typeface="+mn-cs"/>
+            </a:endParaRPr>
+          </a:p>
+          <a:p>
+            <a:r>
+              <a:rPr lang="en-GB" sz="1200" b="1" i="0" kern="1200" dirty="0">
+                <a:solidFill>
+                  <a:schemeClr val="tx1"/>
+                </a:solidFill>
+                <a:effectLst/>
+                <a:latin typeface="+mn-lt"/>
+                <a:ea typeface="+mn-ea"/>
+                <a:cs typeface="+mn-cs"/>
+              </a:rPr>
+              <a:t>1. Install Prerequisites</a:t>
+            </a:r>
+          </a:p>
+          <a:p>
+            <a:r>
+              <a:rPr lang="en-GB" sz="1200" b="1" i="0" kern="1200" dirty="0">
+                <a:solidFill>
+                  <a:schemeClr val="tx1"/>
+                </a:solidFill>
+                <a:effectLst/>
+                <a:latin typeface="+mn-lt"/>
+                <a:ea typeface="+mn-ea"/>
+                <a:cs typeface="+mn-cs"/>
+              </a:rPr>
+              <a:t>Homebrew</a:t>
+            </a:r>
+            <a:r>
+              <a:rPr lang="en-GB" sz="1200" b="0" i="0" kern="1200" dirty="0">
+                <a:solidFill>
+                  <a:schemeClr val="tx1"/>
+                </a:solidFill>
+                <a:effectLst/>
+                <a:latin typeface="+mn-lt"/>
+                <a:ea typeface="+mn-ea"/>
+                <a:cs typeface="+mn-cs"/>
+              </a:rPr>
+              <a:t>: Install Homebrew for managing dependencies:</a:t>
+            </a:r>
+          </a:p>
+          <a:p>
+            <a:r>
+              <a:rPr lang="en-GB" sz="1200" b="0" i="0" kern="1200" dirty="0">
+                <a:solidFill>
+                  <a:schemeClr val="tx1"/>
+                </a:solidFill>
+                <a:effectLst/>
+                <a:latin typeface="+mn-lt"/>
+                <a:ea typeface="+mn-ea"/>
+                <a:cs typeface="+mn-cs"/>
+              </a:rPr>
+              <a:t>/bin/bash -c "$(curl -</a:t>
+            </a:r>
+            <a:r>
+              <a:rPr lang="en-GB" sz="1200" b="0" i="0" kern="1200" dirty="0" err="1">
+                <a:solidFill>
+                  <a:schemeClr val="tx1"/>
+                </a:solidFill>
+                <a:effectLst/>
+                <a:latin typeface="+mn-lt"/>
+                <a:ea typeface="+mn-ea"/>
+                <a:cs typeface="+mn-cs"/>
+              </a:rPr>
+              <a:t>fsSL</a:t>
+            </a:r>
+            <a:r>
+              <a:rPr lang="en-GB" sz="1200" b="0" i="0" kern="1200" dirty="0">
+                <a:solidFill>
+                  <a:schemeClr val="tx1"/>
+                </a:solidFill>
+                <a:effectLst/>
+                <a:latin typeface="+mn-lt"/>
+                <a:ea typeface="+mn-ea"/>
+                <a:cs typeface="+mn-cs"/>
+              </a:rPr>
+              <a:t> https://</a:t>
+            </a:r>
+            <a:r>
+              <a:rPr lang="en-GB" sz="1200" b="0" i="0" kern="1200" dirty="0" err="1">
+                <a:solidFill>
+                  <a:schemeClr val="tx1"/>
+                </a:solidFill>
+                <a:effectLst/>
+                <a:latin typeface="+mn-lt"/>
+                <a:ea typeface="+mn-ea"/>
+                <a:cs typeface="+mn-cs"/>
+              </a:rPr>
+              <a:t>raw.githubusercontent.com</a:t>
+            </a:r>
+            <a:r>
+              <a:rPr lang="en-GB" sz="1200" b="0" i="0" kern="1200" dirty="0">
+                <a:solidFill>
+                  <a:schemeClr val="tx1"/>
+                </a:solidFill>
+                <a:effectLst/>
+                <a:latin typeface="+mn-lt"/>
+                <a:ea typeface="+mn-ea"/>
+                <a:cs typeface="+mn-cs"/>
+              </a:rPr>
+              <a:t>/Homebrew/install/HEAD/</a:t>
+            </a:r>
+            <a:r>
+              <a:rPr lang="en-GB" sz="1200" b="0" i="0" kern="1200" dirty="0" err="1">
+                <a:solidFill>
+                  <a:schemeClr val="tx1"/>
+                </a:solidFill>
+                <a:effectLst/>
+                <a:latin typeface="+mn-lt"/>
+                <a:ea typeface="+mn-ea"/>
+                <a:cs typeface="+mn-cs"/>
+              </a:rPr>
+              <a:t>install.sh</a:t>
+            </a:r>
+            <a:r>
+              <a:rPr lang="en-GB" sz="1200" b="0" i="0" kern="1200" dirty="0">
+                <a:solidFill>
+                  <a:schemeClr val="tx1"/>
+                </a:solidFill>
+                <a:effectLst/>
+                <a:latin typeface="+mn-lt"/>
+                <a:ea typeface="+mn-ea"/>
+                <a:cs typeface="+mn-cs"/>
+              </a:rPr>
+              <a:t>)"</a:t>
+            </a:r>
+          </a:p>
+          <a:p>
+            <a:r>
+              <a:rPr lang="en-GB" sz="1200" b="1" i="0" kern="1200" dirty="0">
+                <a:solidFill>
+                  <a:schemeClr val="tx1"/>
+                </a:solidFill>
+                <a:effectLst/>
+                <a:latin typeface="+mn-lt"/>
+                <a:ea typeface="+mn-ea"/>
+                <a:cs typeface="+mn-cs"/>
+              </a:rPr>
+              <a:t>Node.js and </a:t>
+            </a:r>
+            <a:r>
+              <a:rPr lang="en-GB" sz="1200" b="1" i="0" kern="1200" dirty="0" err="1">
+                <a:solidFill>
+                  <a:schemeClr val="tx1"/>
+                </a:solidFill>
+                <a:effectLst/>
+                <a:latin typeface="+mn-lt"/>
+                <a:ea typeface="+mn-ea"/>
+                <a:cs typeface="+mn-cs"/>
+              </a:rPr>
+              <a:t>npm</a:t>
+            </a:r>
+            <a:r>
+              <a:rPr lang="en-GB" sz="1200" b="0" i="0" kern="1200" dirty="0">
+                <a:solidFill>
+                  <a:schemeClr val="tx1"/>
+                </a:solidFill>
+                <a:effectLst/>
+                <a:latin typeface="+mn-lt"/>
+                <a:ea typeface="+mn-ea"/>
+                <a:cs typeface="+mn-cs"/>
+              </a:rPr>
+              <a:t>: Install Node.js and </a:t>
+            </a:r>
+            <a:r>
+              <a:rPr lang="en-GB" sz="1200" b="0" i="0" kern="1200" dirty="0" err="1">
+                <a:solidFill>
+                  <a:schemeClr val="tx1"/>
+                </a:solidFill>
+                <a:effectLst/>
+                <a:latin typeface="+mn-lt"/>
+                <a:ea typeface="+mn-ea"/>
+                <a:cs typeface="+mn-cs"/>
+              </a:rPr>
+              <a:t>npm</a:t>
+            </a:r>
+            <a:r>
+              <a:rPr lang="en-GB" sz="1200" b="0" i="0" kern="1200" dirty="0">
+                <a:solidFill>
+                  <a:schemeClr val="tx1"/>
+                </a:solidFill>
+                <a:effectLst/>
+                <a:latin typeface="+mn-lt"/>
+                <a:ea typeface="+mn-ea"/>
+                <a:cs typeface="+mn-cs"/>
+              </a:rPr>
+              <a:t> using Homebrew:</a:t>
+            </a:r>
+          </a:p>
+          <a:p>
+            <a:r>
+              <a:rPr lang="en-GB" sz="1200" b="0" i="0" kern="1200" dirty="0">
+                <a:solidFill>
+                  <a:schemeClr val="tx1"/>
+                </a:solidFill>
+                <a:effectLst/>
+                <a:latin typeface="+mn-lt"/>
+                <a:ea typeface="+mn-ea"/>
+                <a:cs typeface="+mn-cs"/>
+              </a:rPr>
+              <a:t>brew install node</a:t>
+            </a:r>
+          </a:p>
+          <a:p>
+            <a:r>
+              <a:rPr lang="en-GB" sz="1200" b="1" i="0" kern="1200" dirty="0">
+                <a:solidFill>
+                  <a:schemeClr val="tx1"/>
+                </a:solidFill>
+                <a:effectLst/>
+                <a:latin typeface="+mn-lt"/>
+                <a:ea typeface="+mn-ea"/>
+                <a:cs typeface="+mn-cs"/>
+              </a:rPr>
+              <a:t>Carthage</a:t>
+            </a:r>
+            <a:r>
+              <a:rPr lang="en-GB" sz="1200" b="0" i="0" kern="1200" dirty="0">
+                <a:solidFill>
+                  <a:schemeClr val="tx1"/>
+                </a:solidFill>
+                <a:effectLst/>
+                <a:latin typeface="+mn-lt"/>
+                <a:ea typeface="+mn-ea"/>
+                <a:cs typeface="+mn-cs"/>
+              </a:rPr>
+              <a:t>: Install Carthage for dependency management:</a:t>
+            </a:r>
+          </a:p>
+          <a:p>
+            <a:r>
+              <a:rPr lang="en-GB" sz="1200" b="0" i="0" kern="1200" dirty="0">
+                <a:solidFill>
+                  <a:schemeClr val="tx1"/>
+                </a:solidFill>
+                <a:effectLst/>
+                <a:latin typeface="+mn-lt"/>
+                <a:ea typeface="+mn-ea"/>
+                <a:cs typeface="+mn-cs"/>
+              </a:rPr>
+              <a:t>brew install </a:t>
+            </a:r>
+            <a:r>
+              <a:rPr lang="en-GB" sz="1200" b="0" i="0" kern="1200" dirty="0" err="1">
+                <a:solidFill>
+                  <a:schemeClr val="tx1"/>
+                </a:solidFill>
+                <a:effectLst/>
+                <a:latin typeface="+mn-lt"/>
+                <a:ea typeface="+mn-ea"/>
+                <a:cs typeface="+mn-cs"/>
+              </a:rPr>
+              <a:t>carthage</a:t>
+            </a:r>
+            <a:endParaRPr lang="en-GB" sz="1200" b="0" i="0" kern="1200" dirty="0">
+              <a:solidFill>
+                <a:schemeClr val="tx1"/>
+              </a:solidFill>
+              <a:effectLst/>
+              <a:latin typeface="+mn-lt"/>
+              <a:ea typeface="+mn-ea"/>
+              <a:cs typeface="+mn-cs"/>
+            </a:endParaRPr>
+          </a:p>
+          <a:p>
+            <a:endParaRPr lang="en-GB" sz="1200" b="1" i="0" kern="1200" dirty="0">
+              <a:solidFill>
+                <a:schemeClr val="tx1"/>
+              </a:solidFill>
+              <a:effectLst/>
+              <a:latin typeface="+mn-lt"/>
+              <a:ea typeface="+mn-ea"/>
+              <a:cs typeface="+mn-cs"/>
+            </a:endParaRPr>
+          </a:p>
+          <a:p>
+            <a:r>
+              <a:rPr lang="en-GB" sz="1200" b="1" i="0" kern="1200" dirty="0">
+                <a:solidFill>
+                  <a:schemeClr val="tx1"/>
+                </a:solidFill>
+                <a:effectLst/>
+                <a:latin typeface="+mn-lt"/>
+                <a:ea typeface="+mn-ea"/>
+                <a:cs typeface="+mn-cs"/>
+              </a:rPr>
+              <a:t>2. Install Java Development Kit (JDK)</a:t>
+            </a:r>
+          </a:p>
+          <a:p>
+            <a:r>
+              <a:rPr lang="en-GB" sz="1200" b="0" i="0" kern="1200" dirty="0">
+                <a:solidFill>
+                  <a:schemeClr val="tx1"/>
+                </a:solidFill>
+                <a:effectLst/>
+                <a:latin typeface="+mn-lt"/>
+                <a:ea typeface="+mn-ea"/>
+                <a:cs typeface="+mn-cs"/>
+              </a:rPr>
+              <a:t>Download and install the JDK from </a:t>
+            </a:r>
+            <a:r>
+              <a:rPr lang="en-GB" sz="1200" b="0" i="0" u="sng" kern="1200" dirty="0">
+                <a:solidFill>
+                  <a:schemeClr val="tx1"/>
+                </a:solidFill>
+                <a:effectLst/>
+                <a:latin typeface="+mn-lt"/>
+                <a:ea typeface="+mn-ea"/>
+                <a:cs typeface="+mn-cs"/>
+                <a:hlinkClick r:id="rId3"/>
+              </a:rPr>
+              <a:t>Oracle's website</a:t>
+            </a:r>
+            <a:r>
+              <a:rPr lang="en-GB" sz="1200" b="0" i="0" kern="1200" dirty="0">
+                <a:solidFill>
+                  <a:schemeClr val="tx1"/>
+                </a:solidFill>
+                <a:effectLst/>
+                <a:latin typeface="+mn-lt"/>
+                <a:ea typeface="+mn-ea"/>
+                <a:cs typeface="+mn-cs"/>
+              </a:rPr>
+              <a:t>.</a:t>
+            </a:r>
+          </a:p>
+          <a:p>
+            <a:r>
+              <a:rPr lang="en-GB" sz="1200" b="0" i="0" kern="1200" dirty="0">
+                <a:solidFill>
+                  <a:schemeClr val="tx1"/>
+                </a:solidFill>
+                <a:effectLst/>
+                <a:latin typeface="+mn-lt"/>
+                <a:ea typeface="+mn-ea"/>
+                <a:cs typeface="+mn-cs"/>
+              </a:rPr>
+              <a:t>Set the JAVA_HOME environment variable:</a:t>
+            </a:r>
+          </a:p>
+          <a:p>
+            <a:r>
+              <a:rPr lang="en-GB" sz="1200" b="0" i="0" kern="1200" dirty="0">
+                <a:solidFill>
+                  <a:schemeClr val="tx1"/>
+                </a:solidFill>
+                <a:effectLst/>
+                <a:latin typeface="+mn-lt"/>
+                <a:ea typeface="+mn-ea"/>
+                <a:cs typeface="+mn-cs"/>
+              </a:rPr>
+              <a:t>export JAVA_HOME=$(/</a:t>
+            </a:r>
+            <a:r>
+              <a:rPr lang="en-GB" sz="1200" b="0" i="0" kern="1200" dirty="0" err="1">
+                <a:solidFill>
+                  <a:schemeClr val="tx1"/>
+                </a:solidFill>
+                <a:effectLst/>
+                <a:latin typeface="+mn-lt"/>
+                <a:ea typeface="+mn-ea"/>
+                <a:cs typeface="+mn-cs"/>
+              </a:rPr>
+              <a:t>usr</a:t>
+            </a:r>
+            <a:r>
+              <a:rPr lang="en-GB" sz="1200" b="0" i="0" kern="1200" dirty="0">
+                <a:solidFill>
+                  <a:schemeClr val="tx1"/>
+                </a:solidFill>
+                <a:effectLst/>
+                <a:latin typeface="+mn-lt"/>
+                <a:ea typeface="+mn-ea"/>
+                <a:cs typeface="+mn-cs"/>
+              </a:rPr>
+              <a:t>/</a:t>
+            </a:r>
+            <a:r>
+              <a:rPr lang="en-GB" sz="1200" b="0" i="0" kern="1200" dirty="0" err="1">
+                <a:solidFill>
+                  <a:schemeClr val="tx1"/>
+                </a:solidFill>
+                <a:effectLst/>
+                <a:latin typeface="+mn-lt"/>
+                <a:ea typeface="+mn-ea"/>
+                <a:cs typeface="+mn-cs"/>
+              </a:rPr>
+              <a:t>libexec</a:t>
+            </a:r>
+            <a:r>
+              <a:rPr lang="en-GB" sz="1200" b="0" i="0" kern="1200" dirty="0">
+                <a:solidFill>
+                  <a:schemeClr val="tx1"/>
+                </a:solidFill>
+                <a:effectLst/>
+                <a:latin typeface="+mn-lt"/>
+                <a:ea typeface="+mn-ea"/>
+                <a:cs typeface="+mn-cs"/>
+              </a:rPr>
+              <a:t>/</a:t>
+            </a:r>
+            <a:r>
+              <a:rPr lang="en-GB" sz="1200" b="0" i="0" kern="1200" dirty="0" err="1">
+                <a:solidFill>
+                  <a:schemeClr val="tx1"/>
+                </a:solidFill>
+                <a:effectLst/>
+                <a:latin typeface="+mn-lt"/>
+                <a:ea typeface="+mn-ea"/>
+                <a:cs typeface="+mn-cs"/>
+              </a:rPr>
+              <a:t>java_home</a:t>
+            </a:r>
+            <a:r>
+              <a:rPr lang="en-GB" sz="1200" b="0" i="0" kern="1200" dirty="0">
+                <a:solidFill>
+                  <a:schemeClr val="tx1"/>
+                </a:solidFill>
+                <a:effectLst/>
+                <a:latin typeface="+mn-lt"/>
+                <a:ea typeface="+mn-ea"/>
+                <a:cs typeface="+mn-cs"/>
+              </a:rPr>
+              <a:t>)</a:t>
+            </a:r>
+          </a:p>
+          <a:p>
+            <a:r>
+              <a:rPr lang="en-GB" sz="1200" b="0" i="0" kern="1200" dirty="0">
+                <a:solidFill>
+                  <a:schemeClr val="tx1"/>
+                </a:solidFill>
+                <a:effectLst/>
+                <a:latin typeface="+mn-lt"/>
+                <a:ea typeface="+mn-ea"/>
+                <a:cs typeface="+mn-cs"/>
+              </a:rPr>
+              <a:t>export PATH=$JAVA_HOME/bin:$PATH</a:t>
+            </a:r>
+          </a:p>
+          <a:p>
+            <a:endParaRPr lang="en-GB" sz="1200" b="1" i="0" kern="1200" dirty="0">
+              <a:solidFill>
+                <a:schemeClr val="tx1"/>
+              </a:solidFill>
+              <a:effectLst/>
+              <a:latin typeface="+mn-lt"/>
+              <a:ea typeface="+mn-ea"/>
+              <a:cs typeface="+mn-cs"/>
+            </a:endParaRPr>
+          </a:p>
+          <a:p>
+            <a:r>
+              <a:rPr lang="en-GB" sz="1200" b="1" i="0" kern="1200" dirty="0">
+                <a:solidFill>
+                  <a:schemeClr val="tx1"/>
+                </a:solidFill>
+                <a:effectLst/>
+                <a:latin typeface="+mn-lt"/>
+                <a:ea typeface="+mn-ea"/>
+                <a:cs typeface="+mn-cs"/>
+              </a:rPr>
+              <a:t>3. Install Xcode and Command-Line Tools</a:t>
+            </a:r>
+          </a:p>
+          <a:p>
+            <a:r>
+              <a:rPr lang="en-GB" sz="1200" b="0" i="0" kern="1200" dirty="0">
+                <a:solidFill>
+                  <a:schemeClr val="tx1"/>
+                </a:solidFill>
+                <a:effectLst/>
+                <a:latin typeface="+mn-lt"/>
+                <a:ea typeface="+mn-ea"/>
+                <a:cs typeface="+mn-cs"/>
+              </a:rPr>
+              <a:t>Download Xcode from the </a:t>
+            </a:r>
+            <a:r>
+              <a:rPr lang="en-GB" sz="1200" b="0" i="0" u="sng" kern="1200" dirty="0">
+                <a:solidFill>
+                  <a:schemeClr val="tx1"/>
+                </a:solidFill>
+                <a:effectLst/>
+                <a:latin typeface="+mn-lt"/>
+                <a:ea typeface="+mn-ea"/>
+                <a:cs typeface="+mn-cs"/>
+                <a:hlinkClick r:id="rId4"/>
+              </a:rPr>
+              <a:t>Mac App Store</a:t>
+            </a:r>
+            <a:r>
+              <a:rPr lang="en-GB" sz="1200" b="0" i="0" kern="1200" dirty="0">
+                <a:solidFill>
+                  <a:schemeClr val="tx1"/>
+                </a:solidFill>
+                <a:effectLst/>
+                <a:latin typeface="+mn-lt"/>
+                <a:ea typeface="+mn-ea"/>
+                <a:cs typeface="+mn-cs"/>
+              </a:rPr>
+              <a:t>.</a:t>
+            </a:r>
+          </a:p>
+          <a:p>
+            <a:r>
+              <a:rPr lang="en-GB" sz="1200" b="0" i="0" kern="1200" dirty="0">
+                <a:solidFill>
+                  <a:schemeClr val="tx1"/>
+                </a:solidFill>
+                <a:effectLst/>
+                <a:latin typeface="+mn-lt"/>
+                <a:ea typeface="+mn-ea"/>
+                <a:cs typeface="+mn-cs"/>
+              </a:rPr>
+              <a:t>Install Xcode command-line tools:</a:t>
+            </a:r>
+          </a:p>
+          <a:p>
+            <a:r>
+              <a:rPr lang="en-GB" sz="1200" b="0" i="0" kern="1200" dirty="0" err="1">
+                <a:solidFill>
+                  <a:schemeClr val="tx1"/>
+                </a:solidFill>
+                <a:effectLst/>
+                <a:latin typeface="+mn-lt"/>
+                <a:ea typeface="+mn-ea"/>
+                <a:cs typeface="+mn-cs"/>
+              </a:rPr>
+              <a:t>xcode</a:t>
+            </a:r>
+            <a:r>
+              <a:rPr lang="en-GB" sz="1200" b="0" i="0" kern="1200" dirty="0">
+                <a:solidFill>
+                  <a:schemeClr val="tx1"/>
+                </a:solidFill>
+                <a:effectLst/>
+                <a:latin typeface="+mn-lt"/>
+                <a:ea typeface="+mn-ea"/>
+                <a:cs typeface="+mn-cs"/>
+              </a:rPr>
+              <a:t>-select --install</a:t>
+            </a:r>
+          </a:p>
+          <a:p>
+            <a:endParaRPr lang="en-GB" sz="1200" b="1" i="0" kern="1200" dirty="0">
+              <a:solidFill>
+                <a:schemeClr val="tx1"/>
+              </a:solidFill>
+              <a:effectLst/>
+              <a:latin typeface="+mn-lt"/>
+              <a:ea typeface="+mn-ea"/>
+              <a:cs typeface="+mn-cs"/>
+            </a:endParaRPr>
+          </a:p>
+          <a:p>
+            <a:r>
+              <a:rPr lang="en-GB" sz="1200" b="1" i="0" kern="1200" dirty="0">
+                <a:solidFill>
+                  <a:schemeClr val="tx1"/>
+                </a:solidFill>
+                <a:effectLst/>
+                <a:latin typeface="+mn-lt"/>
+                <a:ea typeface="+mn-ea"/>
+                <a:cs typeface="+mn-cs"/>
+              </a:rPr>
+              <a:t>4. Install Appium</a:t>
+            </a:r>
+          </a:p>
+          <a:p>
+            <a:r>
+              <a:rPr lang="en-GB" sz="1200" b="0" i="0" kern="1200" dirty="0">
+                <a:solidFill>
+                  <a:schemeClr val="tx1"/>
+                </a:solidFill>
+                <a:effectLst/>
+                <a:latin typeface="+mn-lt"/>
+                <a:ea typeface="+mn-ea"/>
+                <a:cs typeface="+mn-cs"/>
+              </a:rPr>
+              <a:t>Use </a:t>
+            </a:r>
+            <a:r>
+              <a:rPr lang="en-GB" sz="1200" b="0" i="0" kern="1200" dirty="0" err="1">
+                <a:solidFill>
+                  <a:schemeClr val="tx1"/>
+                </a:solidFill>
+                <a:effectLst/>
+                <a:latin typeface="+mn-lt"/>
+                <a:ea typeface="+mn-ea"/>
+                <a:cs typeface="+mn-cs"/>
+              </a:rPr>
+              <a:t>npm</a:t>
+            </a:r>
+            <a:r>
+              <a:rPr lang="en-GB" sz="1200" b="0" i="0" kern="1200" dirty="0">
+                <a:solidFill>
+                  <a:schemeClr val="tx1"/>
+                </a:solidFill>
+                <a:effectLst/>
+                <a:latin typeface="+mn-lt"/>
+                <a:ea typeface="+mn-ea"/>
+                <a:cs typeface="+mn-cs"/>
+              </a:rPr>
+              <a:t> to install Appium globally:</a:t>
+            </a:r>
+          </a:p>
+          <a:p>
+            <a:r>
+              <a:rPr lang="en-GB" sz="1200" b="0" i="0" kern="1200" dirty="0" err="1">
+                <a:solidFill>
+                  <a:schemeClr val="tx1"/>
+                </a:solidFill>
+                <a:effectLst/>
+                <a:latin typeface="+mn-lt"/>
+                <a:ea typeface="+mn-ea"/>
+                <a:cs typeface="+mn-cs"/>
+              </a:rPr>
+              <a:t>npm</a:t>
+            </a:r>
+            <a:r>
+              <a:rPr lang="en-GB" sz="1200" b="0" i="0" kern="1200" dirty="0">
+                <a:solidFill>
+                  <a:schemeClr val="tx1"/>
+                </a:solidFill>
+                <a:effectLst/>
+                <a:latin typeface="+mn-lt"/>
+                <a:ea typeface="+mn-ea"/>
+                <a:cs typeface="+mn-cs"/>
+              </a:rPr>
+              <a:t> install -g </a:t>
+            </a:r>
+            <a:r>
+              <a:rPr lang="en-GB" sz="1200" b="0" i="0" kern="1200" dirty="0" err="1">
+                <a:solidFill>
+                  <a:schemeClr val="tx1"/>
+                </a:solidFill>
+                <a:effectLst/>
+                <a:latin typeface="+mn-lt"/>
+                <a:ea typeface="+mn-ea"/>
+                <a:cs typeface="+mn-cs"/>
+              </a:rPr>
+              <a:t>appium</a:t>
+            </a:r>
+            <a:endParaRPr lang="en-GB" sz="1200" b="0" i="0" kern="1200" dirty="0">
+              <a:solidFill>
+                <a:schemeClr val="tx1"/>
+              </a:solidFill>
+              <a:effectLst/>
+              <a:latin typeface="+mn-lt"/>
+              <a:ea typeface="+mn-ea"/>
+              <a:cs typeface="+mn-cs"/>
+            </a:endParaRPr>
+          </a:p>
+          <a:p>
+            <a:r>
+              <a:rPr lang="en-GB" sz="1200" b="0" i="0" kern="1200" dirty="0">
+                <a:solidFill>
+                  <a:schemeClr val="tx1"/>
+                </a:solidFill>
+                <a:effectLst/>
+                <a:latin typeface="+mn-lt"/>
+                <a:ea typeface="+mn-ea"/>
+                <a:cs typeface="+mn-cs"/>
+              </a:rPr>
+              <a:t>Optionally, install Appium Doctor to verify configurations:</a:t>
+            </a:r>
+          </a:p>
+          <a:p>
+            <a:r>
+              <a:rPr lang="en-GB" sz="1200" b="0" i="0" kern="1200" dirty="0" err="1">
+                <a:solidFill>
+                  <a:schemeClr val="tx1"/>
+                </a:solidFill>
+                <a:effectLst/>
+                <a:latin typeface="+mn-lt"/>
+                <a:ea typeface="+mn-ea"/>
+                <a:cs typeface="+mn-cs"/>
+              </a:rPr>
+              <a:t>npm</a:t>
+            </a:r>
+            <a:r>
+              <a:rPr lang="en-GB" sz="1200" b="0" i="0" kern="1200" dirty="0">
+                <a:solidFill>
+                  <a:schemeClr val="tx1"/>
+                </a:solidFill>
+                <a:effectLst/>
+                <a:latin typeface="+mn-lt"/>
+                <a:ea typeface="+mn-ea"/>
+                <a:cs typeface="+mn-cs"/>
+              </a:rPr>
+              <a:t> install -g </a:t>
+            </a:r>
+            <a:r>
+              <a:rPr lang="en-GB" sz="1200" b="0" i="0" kern="1200" dirty="0" err="1">
+                <a:solidFill>
+                  <a:schemeClr val="tx1"/>
+                </a:solidFill>
+                <a:effectLst/>
+                <a:latin typeface="+mn-lt"/>
+                <a:ea typeface="+mn-ea"/>
+                <a:cs typeface="+mn-cs"/>
+              </a:rPr>
+              <a:t>appium</a:t>
+            </a:r>
+            <a:r>
+              <a:rPr lang="en-GB" sz="1200" b="0" i="0" kern="1200" dirty="0">
+                <a:solidFill>
+                  <a:schemeClr val="tx1"/>
+                </a:solidFill>
+                <a:effectLst/>
+                <a:latin typeface="+mn-lt"/>
+                <a:ea typeface="+mn-ea"/>
+                <a:cs typeface="+mn-cs"/>
+              </a:rPr>
+              <a:t>-doctor</a:t>
+            </a:r>
+          </a:p>
+          <a:p>
+            <a:r>
+              <a:rPr lang="en-GB" sz="1200" b="0" i="0" kern="1200" dirty="0" err="1">
+                <a:solidFill>
+                  <a:schemeClr val="tx1"/>
+                </a:solidFill>
+                <a:effectLst/>
+                <a:latin typeface="+mn-lt"/>
+                <a:ea typeface="+mn-ea"/>
+                <a:cs typeface="+mn-cs"/>
+              </a:rPr>
+              <a:t>appium</a:t>
+            </a:r>
+            <a:r>
+              <a:rPr lang="en-GB" sz="1200" b="0" i="0" kern="1200" dirty="0">
+                <a:solidFill>
+                  <a:schemeClr val="tx1"/>
+                </a:solidFill>
+                <a:effectLst/>
+                <a:latin typeface="+mn-lt"/>
+                <a:ea typeface="+mn-ea"/>
+                <a:cs typeface="+mn-cs"/>
+              </a:rPr>
+              <a:t>-doctor</a:t>
+            </a:r>
+          </a:p>
+          <a:p>
+            <a:endParaRPr lang="en-GB" sz="1200" b="1" i="0" kern="1200" dirty="0">
+              <a:solidFill>
+                <a:schemeClr val="tx1"/>
+              </a:solidFill>
+              <a:effectLst/>
+              <a:latin typeface="+mn-lt"/>
+              <a:ea typeface="+mn-ea"/>
+              <a:cs typeface="+mn-cs"/>
+            </a:endParaRPr>
+          </a:p>
+          <a:p>
+            <a:r>
+              <a:rPr lang="en-GB" sz="1200" b="1" i="0" kern="1200" dirty="0">
+                <a:solidFill>
+                  <a:schemeClr val="tx1"/>
+                </a:solidFill>
+                <a:effectLst/>
+                <a:latin typeface="+mn-lt"/>
+                <a:ea typeface="+mn-ea"/>
+                <a:cs typeface="+mn-cs"/>
+              </a:rPr>
+              <a:t>5. Configure </a:t>
+            </a:r>
+            <a:r>
+              <a:rPr lang="en-GB" sz="1200" b="1" i="0" kern="1200" dirty="0" err="1">
+                <a:solidFill>
+                  <a:schemeClr val="tx1"/>
+                </a:solidFill>
+                <a:effectLst/>
+                <a:latin typeface="+mn-lt"/>
+                <a:ea typeface="+mn-ea"/>
+                <a:cs typeface="+mn-cs"/>
+              </a:rPr>
+              <a:t>WebDriverAgent</a:t>
+            </a:r>
+            <a:endParaRPr lang="en-GB" sz="1200" b="1" i="0" kern="1200" dirty="0">
+              <a:solidFill>
+                <a:schemeClr val="tx1"/>
+              </a:solidFill>
+              <a:effectLst/>
+              <a:latin typeface="+mn-lt"/>
+              <a:ea typeface="+mn-ea"/>
+              <a:cs typeface="+mn-cs"/>
+            </a:endParaRPr>
+          </a:p>
+          <a:p>
+            <a:r>
+              <a:rPr lang="en-GB" sz="1200" b="0" i="0" kern="1200" dirty="0">
+                <a:solidFill>
+                  <a:schemeClr val="tx1"/>
+                </a:solidFill>
+                <a:effectLst/>
+                <a:latin typeface="+mn-lt"/>
+                <a:ea typeface="+mn-ea"/>
+                <a:cs typeface="+mn-cs"/>
+              </a:rPr>
+              <a:t>Navigate to the </a:t>
+            </a:r>
+            <a:r>
+              <a:rPr lang="en-GB" sz="1200" b="0" i="0" kern="1200" dirty="0" err="1">
+                <a:solidFill>
+                  <a:schemeClr val="tx1"/>
+                </a:solidFill>
+                <a:effectLst/>
+                <a:latin typeface="+mn-lt"/>
+                <a:ea typeface="+mn-ea"/>
+                <a:cs typeface="+mn-cs"/>
+              </a:rPr>
+              <a:t>WebDriverAgent</a:t>
+            </a:r>
+            <a:r>
+              <a:rPr lang="en-GB" sz="1200" b="0" i="0" kern="1200" dirty="0">
+                <a:solidFill>
+                  <a:schemeClr val="tx1"/>
+                </a:solidFill>
+                <a:effectLst/>
+                <a:latin typeface="+mn-lt"/>
+                <a:ea typeface="+mn-ea"/>
+                <a:cs typeface="+mn-cs"/>
+              </a:rPr>
+              <a:t> directory (installed with Appium):</a:t>
+            </a:r>
+          </a:p>
+          <a:p>
+            <a:r>
+              <a:rPr lang="en-GB" sz="1200" b="0" i="0" kern="1200" dirty="0">
+                <a:solidFill>
+                  <a:schemeClr val="tx1"/>
+                </a:solidFill>
+                <a:effectLst/>
+                <a:latin typeface="+mn-lt"/>
+                <a:ea typeface="+mn-ea"/>
+                <a:cs typeface="+mn-cs"/>
+              </a:rPr>
+              <a:t>cd /</a:t>
+            </a:r>
+            <a:r>
+              <a:rPr lang="en-GB" sz="1200" b="0" i="0" kern="1200" dirty="0" err="1">
+                <a:solidFill>
+                  <a:schemeClr val="tx1"/>
+                </a:solidFill>
+                <a:effectLst/>
+                <a:latin typeface="+mn-lt"/>
+                <a:ea typeface="+mn-ea"/>
+                <a:cs typeface="+mn-cs"/>
+              </a:rPr>
+              <a:t>usr</a:t>
+            </a:r>
+            <a:r>
+              <a:rPr lang="en-GB" sz="1200" b="0" i="0" kern="1200" dirty="0">
+                <a:solidFill>
+                  <a:schemeClr val="tx1"/>
+                </a:solidFill>
+                <a:effectLst/>
+                <a:latin typeface="+mn-lt"/>
+                <a:ea typeface="+mn-ea"/>
+                <a:cs typeface="+mn-cs"/>
+              </a:rPr>
+              <a:t>/local/lib/</a:t>
+            </a:r>
+            <a:r>
+              <a:rPr lang="en-GB" sz="1200" b="0" i="0" kern="1200" dirty="0" err="1">
+                <a:solidFill>
+                  <a:schemeClr val="tx1"/>
+                </a:solidFill>
+                <a:effectLst/>
+                <a:latin typeface="+mn-lt"/>
+                <a:ea typeface="+mn-ea"/>
+                <a:cs typeface="+mn-cs"/>
+              </a:rPr>
+              <a:t>node_modules</a:t>
+            </a:r>
+            <a:r>
+              <a:rPr lang="en-GB" sz="1200" b="0" i="0" kern="1200" dirty="0">
+                <a:solidFill>
+                  <a:schemeClr val="tx1"/>
+                </a:solidFill>
+                <a:effectLst/>
+                <a:latin typeface="+mn-lt"/>
+                <a:ea typeface="+mn-ea"/>
+                <a:cs typeface="+mn-cs"/>
+              </a:rPr>
+              <a:t>/</a:t>
+            </a:r>
+            <a:r>
+              <a:rPr lang="en-GB" sz="1200" b="0" i="0" kern="1200" dirty="0" err="1">
+                <a:solidFill>
+                  <a:schemeClr val="tx1"/>
+                </a:solidFill>
+                <a:effectLst/>
+                <a:latin typeface="+mn-lt"/>
+                <a:ea typeface="+mn-ea"/>
+                <a:cs typeface="+mn-cs"/>
+              </a:rPr>
+              <a:t>appium</a:t>
+            </a:r>
+            <a:r>
+              <a:rPr lang="en-GB" sz="1200" b="0" i="0" kern="1200" dirty="0">
+                <a:solidFill>
+                  <a:schemeClr val="tx1"/>
+                </a:solidFill>
+                <a:effectLst/>
+                <a:latin typeface="+mn-lt"/>
+                <a:ea typeface="+mn-ea"/>
+                <a:cs typeface="+mn-cs"/>
+              </a:rPr>
+              <a:t>/</a:t>
+            </a:r>
+            <a:r>
+              <a:rPr lang="en-GB" sz="1200" b="0" i="0" kern="1200" dirty="0" err="1">
+                <a:solidFill>
+                  <a:schemeClr val="tx1"/>
+                </a:solidFill>
+                <a:effectLst/>
+                <a:latin typeface="+mn-lt"/>
+                <a:ea typeface="+mn-ea"/>
+                <a:cs typeface="+mn-cs"/>
+              </a:rPr>
+              <a:t>node_modules</a:t>
+            </a:r>
+            <a:r>
+              <a:rPr lang="en-GB" sz="1200" b="0" i="0" kern="1200" dirty="0">
+                <a:solidFill>
+                  <a:schemeClr val="tx1"/>
+                </a:solidFill>
+                <a:effectLst/>
+                <a:latin typeface="+mn-lt"/>
+                <a:ea typeface="+mn-ea"/>
+                <a:cs typeface="+mn-cs"/>
+              </a:rPr>
+              <a:t>/</a:t>
+            </a:r>
+            <a:r>
+              <a:rPr lang="en-GB" sz="1200" b="0" i="0" kern="1200" dirty="0" err="1">
+                <a:solidFill>
+                  <a:schemeClr val="tx1"/>
+                </a:solidFill>
+                <a:effectLst/>
+                <a:latin typeface="+mn-lt"/>
+                <a:ea typeface="+mn-ea"/>
+                <a:cs typeface="+mn-cs"/>
+              </a:rPr>
+              <a:t>appium-webdriveragent</a:t>
+            </a:r>
+            <a:endParaRPr lang="en-GB" sz="1200" b="0" i="0" kern="1200" dirty="0">
+              <a:solidFill>
+                <a:schemeClr val="tx1"/>
+              </a:solidFill>
+              <a:effectLst/>
+              <a:latin typeface="+mn-lt"/>
+              <a:ea typeface="+mn-ea"/>
+              <a:cs typeface="+mn-cs"/>
+            </a:endParaRPr>
+          </a:p>
+          <a:p>
+            <a:r>
+              <a:rPr lang="en-GB" sz="1200" b="0" i="0" kern="1200" dirty="0">
+                <a:solidFill>
+                  <a:schemeClr val="tx1"/>
+                </a:solidFill>
+                <a:effectLst/>
+                <a:latin typeface="+mn-lt"/>
+                <a:ea typeface="+mn-ea"/>
+                <a:cs typeface="+mn-cs"/>
+              </a:rPr>
+              <a:t>Bootstrap dependencies:</a:t>
+            </a:r>
+          </a:p>
+          <a:p>
+            <a:r>
+              <a:rPr lang="en-GB" sz="1200" b="0" i="0" kern="1200" dirty="0">
+                <a:solidFill>
+                  <a:schemeClr val="tx1"/>
+                </a:solidFill>
+                <a:effectLst/>
+                <a:latin typeface="+mn-lt"/>
+                <a:ea typeface="+mn-ea"/>
+                <a:cs typeface="+mn-cs"/>
+              </a:rPr>
+              <a:t>/Scripts/</a:t>
+            </a:r>
+            <a:r>
+              <a:rPr lang="en-GB" sz="1200" b="0" i="0" kern="1200" dirty="0" err="1">
+                <a:solidFill>
+                  <a:schemeClr val="tx1"/>
+                </a:solidFill>
+                <a:effectLst/>
+                <a:latin typeface="+mn-lt"/>
+                <a:ea typeface="+mn-ea"/>
+                <a:cs typeface="+mn-cs"/>
+              </a:rPr>
+              <a:t>bootstrap.sh</a:t>
+            </a:r>
+            <a:r>
+              <a:rPr lang="en-GB" sz="1200" b="0" i="0" kern="1200" dirty="0">
+                <a:solidFill>
+                  <a:schemeClr val="tx1"/>
+                </a:solidFill>
+                <a:effectLst/>
+                <a:latin typeface="+mn-lt"/>
+                <a:ea typeface="+mn-ea"/>
+                <a:cs typeface="+mn-cs"/>
+              </a:rPr>
+              <a:t> -d</a:t>
+            </a:r>
+          </a:p>
+          <a:p>
+            <a:r>
+              <a:rPr lang="en-GB" sz="1200" b="0" i="0" kern="1200" dirty="0">
+                <a:solidFill>
+                  <a:schemeClr val="tx1"/>
+                </a:solidFill>
+                <a:effectLst/>
+                <a:latin typeface="+mn-lt"/>
+                <a:ea typeface="+mn-ea"/>
+                <a:cs typeface="+mn-cs"/>
+              </a:rPr>
+              <a:t>Open </a:t>
+            </a:r>
+            <a:r>
+              <a:rPr lang="en-GB" sz="1200" b="0" i="0" kern="1200" dirty="0" err="1">
+                <a:solidFill>
+                  <a:schemeClr val="tx1"/>
+                </a:solidFill>
+                <a:effectLst/>
+                <a:latin typeface="+mn-lt"/>
+                <a:ea typeface="+mn-ea"/>
+                <a:cs typeface="+mn-cs"/>
+              </a:rPr>
+              <a:t>WebDriverAgent.xcodeproj</a:t>
+            </a:r>
+            <a:r>
+              <a:rPr lang="en-GB" sz="1200" b="0" i="0" kern="1200" dirty="0">
+                <a:solidFill>
+                  <a:schemeClr val="tx1"/>
+                </a:solidFill>
+                <a:effectLst/>
+                <a:latin typeface="+mn-lt"/>
+                <a:ea typeface="+mn-ea"/>
+                <a:cs typeface="+mn-cs"/>
+              </a:rPr>
+              <a:t> in Xcode, set your development team, and build the project:</a:t>
+            </a:r>
+          </a:p>
+          <a:p>
+            <a:r>
+              <a:rPr lang="en-GB" sz="1200" b="0" i="0" kern="1200" dirty="0" err="1">
+                <a:solidFill>
+                  <a:schemeClr val="tx1"/>
+                </a:solidFill>
+                <a:effectLst/>
+                <a:latin typeface="+mn-lt"/>
+                <a:ea typeface="+mn-ea"/>
+                <a:cs typeface="+mn-cs"/>
+              </a:rPr>
+              <a:t>xcodebuild</a:t>
+            </a:r>
+            <a:r>
+              <a:rPr lang="en-GB" sz="1200" b="0" i="0" kern="1200" dirty="0">
+                <a:solidFill>
+                  <a:schemeClr val="tx1"/>
+                </a:solidFill>
+                <a:effectLst/>
+                <a:latin typeface="+mn-lt"/>
+                <a:ea typeface="+mn-ea"/>
+                <a:cs typeface="+mn-cs"/>
+              </a:rPr>
+              <a:t> -project </a:t>
+            </a:r>
+            <a:r>
+              <a:rPr lang="en-GB" sz="1200" b="0" i="0" kern="1200" dirty="0" err="1">
+                <a:solidFill>
+                  <a:schemeClr val="tx1"/>
+                </a:solidFill>
+                <a:effectLst/>
+                <a:latin typeface="+mn-lt"/>
+                <a:ea typeface="+mn-ea"/>
+                <a:cs typeface="+mn-cs"/>
+              </a:rPr>
+              <a:t>WebDriverAgent.xcodeproj</a:t>
+            </a:r>
+            <a:r>
+              <a:rPr lang="en-GB" sz="1200" b="0" i="0" kern="1200" dirty="0">
+                <a:solidFill>
+                  <a:schemeClr val="tx1"/>
+                </a:solidFill>
+                <a:effectLst/>
+                <a:latin typeface="+mn-lt"/>
+                <a:ea typeface="+mn-ea"/>
+                <a:cs typeface="+mn-cs"/>
+              </a:rPr>
+              <a:t> -scheme </a:t>
+            </a:r>
+            <a:r>
+              <a:rPr lang="en-GB" sz="1200" b="0" i="0" kern="1200" dirty="0" err="1">
+                <a:solidFill>
+                  <a:schemeClr val="tx1"/>
+                </a:solidFill>
+                <a:effectLst/>
+                <a:latin typeface="+mn-lt"/>
+                <a:ea typeface="+mn-ea"/>
+                <a:cs typeface="+mn-cs"/>
+              </a:rPr>
+              <a:t>WebDriverAgentRunner</a:t>
+            </a:r>
+            <a:r>
+              <a:rPr lang="en-GB" sz="1200" b="0" i="0" kern="1200" dirty="0">
+                <a:solidFill>
+                  <a:schemeClr val="tx1"/>
+                </a:solidFill>
+                <a:effectLst/>
+                <a:latin typeface="+mn-lt"/>
+                <a:ea typeface="+mn-ea"/>
+                <a:cs typeface="+mn-cs"/>
+              </a:rPr>
+              <a:t> -destination 'id=&lt;</a:t>
+            </a:r>
+            <a:r>
+              <a:rPr lang="en-GB" sz="1200" b="0" i="0" kern="1200" dirty="0" err="1">
+                <a:solidFill>
+                  <a:schemeClr val="tx1"/>
+                </a:solidFill>
+                <a:effectLst/>
+                <a:latin typeface="+mn-lt"/>
+                <a:ea typeface="+mn-ea"/>
+                <a:cs typeface="+mn-cs"/>
+              </a:rPr>
+              <a:t>device_udid</a:t>
+            </a:r>
+            <a:r>
+              <a:rPr lang="en-GB" sz="1200" b="0" i="0" kern="1200" dirty="0">
+                <a:solidFill>
+                  <a:schemeClr val="tx1"/>
+                </a:solidFill>
+                <a:effectLst/>
+                <a:latin typeface="+mn-lt"/>
+                <a:ea typeface="+mn-ea"/>
+                <a:cs typeface="+mn-cs"/>
+              </a:rPr>
+              <a:t>&gt;' test</a:t>
+            </a:r>
+          </a:p>
+          <a:p>
+            <a:endParaRPr lang="en-GB" sz="1200" b="1" i="0" kern="1200" dirty="0">
+              <a:solidFill>
+                <a:schemeClr val="tx1"/>
+              </a:solidFill>
+              <a:effectLst/>
+              <a:latin typeface="+mn-lt"/>
+              <a:ea typeface="+mn-ea"/>
+              <a:cs typeface="+mn-cs"/>
+            </a:endParaRPr>
+          </a:p>
+          <a:p>
+            <a:r>
+              <a:rPr lang="en-GB" sz="1200" b="1" i="0" kern="1200" dirty="0">
+                <a:solidFill>
+                  <a:schemeClr val="tx1"/>
+                </a:solidFill>
+                <a:effectLst/>
+                <a:latin typeface="+mn-lt"/>
+                <a:ea typeface="+mn-ea"/>
+                <a:cs typeface="+mn-cs"/>
+              </a:rPr>
+              <a:t>6. Verify Setup</a:t>
+            </a:r>
+          </a:p>
+          <a:p>
+            <a:r>
+              <a:rPr lang="en-GB" sz="1200" b="0" i="0" kern="1200" dirty="0">
+                <a:solidFill>
+                  <a:schemeClr val="tx1"/>
+                </a:solidFill>
+                <a:effectLst/>
+                <a:latin typeface="+mn-lt"/>
+                <a:ea typeface="+mn-ea"/>
+                <a:cs typeface="+mn-cs"/>
+              </a:rPr>
+              <a:t>Start the Appium server:</a:t>
+            </a:r>
+          </a:p>
+          <a:p>
+            <a:r>
+              <a:rPr lang="en-GB" sz="1200" b="0" i="0" kern="1200" dirty="0" err="1">
+                <a:solidFill>
+                  <a:schemeClr val="tx1"/>
+                </a:solidFill>
+                <a:effectLst/>
+                <a:latin typeface="+mn-lt"/>
+                <a:ea typeface="+mn-ea"/>
+                <a:cs typeface="+mn-cs"/>
+              </a:rPr>
+              <a:t>appium</a:t>
+            </a:r>
+            <a:endParaRPr lang="en-GB" sz="1200" b="0" i="0" kern="1200" dirty="0">
+              <a:solidFill>
+                <a:schemeClr val="tx1"/>
+              </a:solidFill>
+              <a:effectLst/>
+              <a:latin typeface="+mn-lt"/>
+              <a:ea typeface="+mn-ea"/>
+              <a:cs typeface="+mn-cs"/>
+            </a:endParaRPr>
+          </a:p>
+          <a:p>
+            <a:r>
+              <a:rPr lang="en-GB" sz="1200" b="0" i="0" kern="1200" dirty="0">
+                <a:solidFill>
+                  <a:schemeClr val="tx1"/>
+                </a:solidFill>
+                <a:effectLst/>
+                <a:latin typeface="+mn-lt"/>
+                <a:ea typeface="+mn-ea"/>
+                <a:cs typeface="+mn-cs"/>
+              </a:rPr>
+              <a:t>Use Appium Inspector or your test scripts to validate the setup.</a:t>
+            </a:r>
+          </a:p>
+          <a:p>
+            <a:endParaRPr lang="en-GB" sz="1200" b="0" i="0" kern="1200" dirty="0">
+              <a:solidFill>
+                <a:schemeClr val="tx1"/>
+              </a:solidFill>
+              <a:effectLst/>
+              <a:latin typeface="+mn-lt"/>
+              <a:ea typeface="+mn-ea"/>
+              <a:cs typeface="+mn-cs"/>
+            </a:endParaRPr>
+          </a:p>
+          <a:p>
+            <a:r>
+              <a:rPr lang="en-GB" sz="1200" b="1" i="0" kern="1200" dirty="0">
+                <a:solidFill>
+                  <a:schemeClr val="tx1"/>
+                </a:solidFill>
+                <a:effectLst/>
+                <a:latin typeface="+mn-lt"/>
+                <a:ea typeface="+mn-ea"/>
+                <a:cs typeface="+mn-cs"/>
+              </a:rPr>
+              <a:t>Tips</a:t>
+            </a:r>
+          </a:p>
+          <a:p>
+            <a:r>
+              <a:rPr lang="en-GB" sz="1200" b="0" i="0" kern="1200" dirty="0">
+                <a:solidFill>
+                  <a:schemeClr val="tx1"/>
+                </a:solidFill>
+                <a:effectLst/>
+                <a:latin typeface="+mn-lt"/>
+                <a:ea typeface="+mn-ea"/>
+                <a:cs typeface="+mn-cs"/>
+              </a:rPr>
+              <a:t>Ensure you have an Apple Developer account for provisioning profiles.</a:t>
+            </a:r>
+          </a:p>
+          <a:p>
+            <a:r>
+              <a:rPr lang="en-GB" sz="1200" b="0" i="0" kern="1200" dirty="0">
+                <a:solidFill>
+                  <a:schemeClr val="tx1"/>
+                </a:solidFill>
+                <a:effectLst/>
+                <a:latin typeface="+mn-lt"/>
+                <a:ea typeface="+mn-ea"/>
+                <a:cs typeface="+mn-cs"/>
+              </a:rPr>
+              <a:t>Use </a:t>
+            </a:r>
+            <a:r>
+              <a:rPr lang="en-GB" sz="1200" b="0" i="0" kern="1200" dirty="0" err="1">
+                <a:solidFill>
+                  <a:schemeClr val="tx1"/>
+                </a:solidFill>
+                <a:effectLst/>
+                <a:latin typeface="+mn-lt"/>
+                <a:ea typeface="+mn-ea"/>
+                <a:cs typeface="+mn-cs"/>
+              </a:rPr>
+              <a:t>appium</a:t>
+            </a:r>
+            <a:r>
+              <a:rPr lang="en-GB" sz="1200" b="0" i="0" kern="1200" dirty="0">
+                <a:solidFill>
+                  <a:schemeClr val="tx1"/>
+                </a:solidFill>
+                <a:effectLst/>
+                <a:latin typeface="+mn-lt"/>
+                <a:ea typeface="+mn-ea"/>
+                <a:cs typeface="+mn-cs"/>
+              </a:rPr>
+              <a:t>-doctor frequently to troubleshoot configuration issues.</a:t>
+            </a:r>
+          </a:p>
+          <a:p>
+            <a:r>
+              <a:rPr lang="en-GB" sz="1200" b="0" i="0" kern="1200" dirty="0">
+                <a:solidFill>
+                  <a:schemeClr val="tx1"/>
+                </a:solidFill>
+                <a:effectLst/>
+                <a:latin typeface="+mn-lt"/>
+                <a:ea typeface="+mn-ea"/>
+                <a:cs typeface="+mn-cs"/>
+              </a:rPr>
+              <a:t>For scalable testing, consider cloud platforms like </a:t>
+            </a:r>
+            <a:r>
+              <a:rPr lang="en-GB" sz="1200" b="0" i="0" kern="1200" dirty="0" err="1">
+                <a:solidFill>
+                  <a:schemeClr val="tx1"/>
+                </a:solidFill>
+                <a:effectLst/>
+                <a:latin typeface="+mn-lt"/>
+                <a:ea typeface="+mn-ea"/>
+                <a:cs typeface="+mn-cs"/>
+              </a:rPr>
+              <a:t>BrowserStack</a:t>
+            </a:r>
+            <a:r>
+              <a:rPr lang="en-GB" sz="1200" b="0" i="0" kern="1200" dirty="0">
+                <a:solidFill>
+                  <a:schemeClr val="tx1"/>
+                </a:solidFill>
+                <a:effectLst/>
+                <a:latin typeface="+mn-lt"/>
+                <a:ea typeface="+mn-ea"/>
+                <a:cs typeface="+mn-cs"/>
+              </a:rPr>
+              <a:t>.</a:t>
+            </a:r>
+          </a:p>
+        </p:txBody>
+      </p:sp>
+      <p:sp>
+        <p:nvSpPr>
+          <p:cNvPr id="4" name="Slide Number Placeholder 3"/>
+          <p:cNvSpPr>
+            <a:spLocks noGrp="1"/>
+          </p:cNvSpPr>
+          <p:nvPr>
+            <p:ph type="sldNum" sz="quarter" idx="5"/>
+          </p:nvPr>
+        </p:nvSpPr>
+        <p:spPr/>
+        <p:txBody>
+          <a:bodyPr/>
+          <a:lstStyle/>
+          <a:p>
+            <a:fld id="{1DB0C060-F7D4-4C65-826A-795CA5BE88E2}" type="slidenum">
+              <a:rPr lang="fr-FR" noProof="0" smtClean="0"/>
+              <a:t>8</a:t>
+            </a:fld>
+            <a:endParaRPr lang="fr-FR" noProof="0"/>
+          </a:p>
+        </p:txBody>
+      </p:sp>
+    </p:spTree>
+    <p:extLst>
+      <p:ext uri="{BB962C8B-B14F-4D97-AF65-F5344CB8AC3E}">
+        <p14:creationId xmlns:p14="http://schemas.microsoft.com/office/powerpoint/2010/main" val="3683009031"/>
+      </p:ext>
+    </p:extLst>
+  </p:cSld>
+  <p:clrMapOvr>
+    <a:masterClrMapping/>
+  </p:clrMapOvr>
+</p:notes>
+</file>
+
 <file path=ppt/slideLayouts/slideLayout1.xml><?xml version="1.0" encoding="utf-8"?>
 <p:sldLayout xmlns:a="http://schemas.openxmlformats.org/drawingml/2006/main" xmlns:r="http://schemas.openxmlformats.org/officeDocument/2006/relationships" xmlns:p="http://schemas.openxmlformats.org/presentationml/2006/main" showMasterSp="0" type="title" preserve="1">
   <p:cSld name="Diapositive de titre">
@@ -1776,7 +3222,7 @@
             <a:pPr rtl="0"/>
             <a:fld id="{92829AA3-688F-4FAF-9C70-2EAED5DE0A5F}" type="datetime1">
               <a:rPr lang="fr-FR" noProof="0" smtClean="0"/>
-              <a:t>16/03/2026</a:t>
+              <a:t>01/05/2026</a:t>
             </a:fld>
             <a:endParaRPr lang="fr-FR" noProof="0"/>
           </a:p>
@@ -1832,7 +3278,7 @@
             <a:pPr rtl="0"/>
             <a:fld id="{3A98EE3D-8CD1-4C3F-BD1C-C98C9596463C}" type="slidenum">
               <a:rPr lang="fr-FR" noProof="0" smtClean="0"/>
-              <a:t>‹N°›</a:t>
+              <a:t>‹#›</a:t>
             </a:fld>
             <a:endParaRPr lang="fr-FR" noProof="0"/>
           </a:p>
@@ -1967,7 +3413,7 @@
             <a:pPr rtl="0"/>
             <a:fld id="{0F708A2A-6F02-48A2-99AD-832CF5AA71DA}" type="datetime1">
               <a:rPr lang="fr-FR" noProof="0" smtClean="0"/>
-              <a:t>16/03/2026</a:t>
+              <a:t>01/05/2026</a:t>
             </a:fld>
             <a:endParaRPr lang="fr-FR" noProof="0"/>
           </a:p>
@@ -2023,7 +3469,7 @@
             <a:pPr rtl="0"/>
             <a:fld id="{3A98EE3D-8CD1-4C3F-BD1C-C98C9596463C}" type="slidenum">
               <a:rPr lang="fr-FR" noProof="0" smtClean="0"/>
-              <a:t>‹N°›</a:t>
+              <a:t>‹#›</a:t>
             </a:fld>
             <a:endParaRPr lang="fr-FR" noProof="0"/>
           </a:p>
@@ -2213,7 +3659,7 @@
             <a:pPr rtl="0"/>
             <a:fld id="{0F708A2A-6F02-48A2-99AD-832CF5AA71DA}" type="datetime1">
               <a:rPr lang="fr-FR" noProof="0" smtClean="0"/>
-              <a:t>16/03/2026</a:t>
+              <a:t>01/05/2026</a:t>
             </a:fld>
             <a:endParaRPr lang="fr-FR" noProof="0"/>
           </a:p>
@@ -2269,7 +3715,7 @@
             <a:pPr rtl="0"/>
             <a:fld id="{3A98EE3D-8CD1-4C3F-BD1C-C98C9596463C}" type="slidenum">
               <a:rPr lang="fr-FR" noProof="0" smtClean="0"/>
-              <a:t>‹N°›</a:t>
+              <a:t>‹#›</a:t>
             </a:fld>
             <a:endParaRPr lang="fr-FR" noProof="0"/>
           </a:p>
@@ -2405,7 +3851,7 @@
             <a:pPr rtl="0"/>
             <a:fld id="{3B779C31-26A2-4001-8DD7-CEA4A5920D6F}" type="datetime1">
               <a:rPr lang="fr-FR" noProof="0" smtClean="0"/>
-              <a:t>16/03/2026</a:t>
+              <a:t>01/05/2026</a:t>
             </a:fld>
             <a:endParaRPr lang="fr-FR" noProof="0"/>
           </a:p>
@@ -2461,7 +3907,7 @@
             <a:pPr rtl="0"/>
             <a:fld id="{3A98EE3D-8CD1-4C3F-BD1C-C98C9596463C}" type="slidenum">
               <a:rPr lang="fr-FR" noProof="0" smtClean="0"/>
-              <a:t>‹N°›</a:t>
+              <a:t>‹#›</a:t>
             </a:fld>
             <a:endParaRPr lang="fr-FR" noProof="0"/>
           </a:p>
@@ -2773,7 +4219,7 @@
             <a:pPr rtl="0"/>
             <a:fld id="{0F708A2A-6F02-48A2-99AD-832CF5AA71DA}" type="datetime1">
               <a:rPr lang="fr-FR" noProof="0" smtClean="0"/>
-              <a:t>16/03/2026</a:t>
+              <a:t>01/05/2026</a:t>
             </a:fld>
             <a:endParaRPr lang="fr-FR" noProof="0"/>
           </a:p>
@@ -2829,7 +4275,7 @@
             <a:pPr rtl="0"/>
             <a:fld id="{3A98EE3D-8CD1-4C3F-BD1C-C98C9596463C}" type="slidenum">
               <a:rPr lang="fr-FR" noProof="0" smtClean="0"/>
-              <a:t>‹N°›</a:t>
+              <a:t>‹#›</a:t>
             </a:fld>
             <a:endParaRPr lang="fr-FR" noProof="0"/>
           </a:p>
@@ -3004,7 +4450,7 @@
             <a:pPr rtl="0"/>
             <a:fld id="{0F708A2A-6F02-48A2-99AD-832CF5AA71DA}" type="datetime1">
               <a:rPr lang="fr-FR" noProof="0" smtClean="0"/>
-              <a:t>16/03/2026</a:t>
+              <a:t>01/05/2026</a:t>
             </a:fld>
             <a:endParaRPr lang="fr-FR" noProof="0"/>
           </a:p>
@@ -3060,7 +4506,7 @@
             <a:pPr rtl="0"/>
             <a:fld id="{3A98EE3D-8CD1-4C3F-BD1C-C98C9596463C}" type="slidenum">
               <a:rPr lang="fr-FR" noProof="0" smtClean="0"/>
-              <a:t>‹N°›</a:t>
+              <a:t>‹#›</a:t>
             </a:fld>
             <a:endParaRPr lang="fr-FR" noProof="0"/>
           </a:p>
@@ -3438,7 +4884,7 @@
             <a:pPr rtl="0"/>
             <a:fld id="{1E313F57-3095-42DA-A8AD-EACF93632B45}" type="datetime1">
               <a:rPr lang="fr-FR" noProof="0" smtClean="0"/>
-              <a:t>16/03/2026</a:t>
+              <a:t>01/05/2026</a:t>
             </a:fld>
             <a:endParaRPr lang="fr-FR" noProof="0"/>
           </a:p>
@@ -3494,7 +4940,7 @@
             <a:pPr rtl="0"/>
             <a:fld id="{3A98EE3D-8CD1-4C3F-BD1C-C98C9596463C}" type="slidenum">
               <a:rPr lang="fr-FR" noProof="0" smtClean="0"/>
-              <a:t>‹N°›</a:t>
+              <a:t>‹#›</a:t>
             </a:fld>
             <a:endParaRPr lang="fr-FR" noProof="0"/>
           </a:p>
@@ -3577,7 +5023,7 @@
             <a:pPr rtl="0"/>
             <a:fld id="{0F708A2A-6F02-48A2-99AD-832CF5AA71DA}" type="datetime1">
               <a:rPr lang="fr-FR" noProof="0" smtClean="0"/>
-              <a:t>16/03/2026</a:t>
+              <a:t>01/05/2026</a:t>
             </a:fld>
             <a:endParaRPr lang="fr-FR" noProof="0"/>
           </a:p>
@@ -3633,7 +5079,7 @@
             <a:pPr rtl="0"/>
             <a:fld id="{3A98EE3D-8CD1-4C3F-BD1C-C98C9596463C}" type="slidenum">
               <a:rPr lang="fr-FR" noProof="0" smtClean="0"/>
-              <a:t>‹N°›</a:t>
+              <a:t>‹#›</a:t>
             </a:fld>
             <a:endParaRPr lang="fr-FR" noProof="0"/>
           </a:p>
@@ -3738,7 +5184,7 @@
             <a:pPr rtl="0"/>
             <a:fld id="{17C76EA5-DE82-4067-88F3-4BF0BABA598F}" type="datetime1">
               <a:rPr lang="fr-FR" noProof="0" smtClean="0"/>
-              <a:t>16/03/2026</a:t>
+              <a:t>01/05/2026</a:t>
             </a:fld>
             <a:endParaRPr lang="fr-FR" noProof="0"/>
           </a:p>
@@ -3794,7 +5240,7 @@
             <a:pPr rtl="0"/>
             <a:fld id="{3A98EE3D-8CD1-4C3F-BD1C-C98C9596463C}" type="slidenum">
               <a:rPr lang="fr-FR" noProof="0" smtClean="0"/>
-              <a:t>‹N°›</a:t>
+              <a:t>‹#›</a:t>
             </a:fld>
             <a:endParaRPr lang="fr-FR" noProof="0"/>
           </a:p>
@@ -4070,7 +5516,7 @@
             <a:pPr rtl="0"/>
             <a:fld id="{31C46C69-7F73-47D5-86D5-FDA507AE9AA8}" type="datetime1">
               <a:rPr lang="fr-FR" noProof="0" smtClean="0"/>
-              <a:t>16/03/2026</a:t>
+              <a:t>01/05/2026</a:t>
             </a:fld>
             <a:endParaRPr lang="fr-FR" noProof="0"/>
           </a:p>
@@ -4136,7 +5582,7 @@
             <a:fld id="{3A98EE3D-8CD1-4C3F-BD1C-C98C9596463C}" type="slidenum">
               <a:rPr lang="fr-FR" noProof="0" smtClean="0"/>
               <a:pPr rtl="0"/>
-              <a:t>‹N°›</a:t>
+              <a:t>‹#›</a:t>
             </a:fld>
             <a:endParaRPr lang="fr-FR" noProof="0"/>
           </a:p>
@@ -4423,7 +5869,7 @@
             <a:pPr rtl="0"/>
             <a:fld id="{973E1055-39CE-418F-9B0E-741B5617658E}" type="datetime1">
               <a:rPr lang="fr-FR" noProof="0" smtClean="0"/>
-              <a:t>16/03/2026</a:t>
+              <a:t>01/05/2026</a:t>
             </a:fld>
             <a:endParaRPr lang="fr-FR" noProof="0"/>
           </a:p>
@@ -4472,7 +5918,7 @@
             <a:pPr rtl="0"/>
             <a:fld id="{3A98EE3D-8CD1-4C3F-BD1C-C98C9596463C}" type="slidenum">
               <a:rPr lang="fr-FR" noProof="0" smtClean="0"/>
-              <a:t>‹N°›</a:t>
+              <a:t>‹#›</a:t>
             </a:fld>
             <a:endParaRPr lang="fr-FR" noProof="0"/>
           </a:p>
@@ -4686,7 +6132,7 @@
             <a:pPr rtl="0"/>
             <a:fld id="{0F708A2A-6F02-48A2-99AD-832CF5AA71DA}" type="datetime1">
               <a:rPr lang="fr-FR" noProof="0" smtClean="0"/>
-              <a:t>16/03/2026</a:t>
+              <a:t>01/05/2026</a:t>
             </a:fld>
             <a:endParaRPr lang="fr-FR" noProof="0"/>
           </a:p>
@@ -4762,7 +6208,7 @@
             <a:pPr rtl="0"/>
             <a:fld id="{3A98EE3D-8CD1-4C3F-BD1C-C98C9596463C}" type="slidenum">
               <a:rPr lang="fr-FR" noProof="0" smtClean="0"/>
-              <a:t>‹N°›</a:t>
+              <a:t>‹#›</a:t>
             </a:fld>
             <a:endParaRPr lang="fr-FR" noProof="0"/>
           </a:p>
@@ -6303,6 +7749,89 @@
     <p:extLst>
       <p:ext uri="{BB962C8B-B14F-4D97-AF65-F5344CB8AC3E}">
         <p14:creationId xmlns:p14="http://schemas.microsoft.com/office/powerpoint/2010/main" val="3967154747"/>
+      </p:ext>
+    </p:extLst>
+  </p:cSld>
+  <p:clrMapOvr>
+    <a:masterClrMapping/>
+  </p:clrMapOvr>
+</p:sld>
+</file>
+
+<file path=ppt/slides/slide8.xml><?xml version="1.0" encoding="utf-8"?>
+<p:sld xmlns:a="http://schemas.openxmlformats.org/drawingml/2006/main" xmlns:r="http://schemas.openxmlformats.org/officeDocument/2006/relationships" xmlns:p="http://schemas.openxmlformats.org/presentationml/2006/main">
+  <p:cSld>
+    <p:spTree>
+      <p:nvGrpSpPr>
+        <p:cNvPr id="1" name=""/>
+        <p:cNvGrpSpPr/>
+        <p:nvPr/>
+      </p:nvGrpSpPr>
+      <p:grpSpPr>
+        <a:xfrm>
+          <a:off x="0" y="0"/>
+          <a:ext cx="0" cy="0"/>
+          <a:chOff x="0" y="0"/>
+          <a:chExt cx="0" cy="0"/>
+        </a:xfrm>
+      </p:grpSpPr>
+      <p:sp>
+        <p:nvSpPr>
+          <p:cNvPr id="2" name="Title 1">
+            <a:extLst>
+              <a:ext uri="{FF2B5EF4-FFF2-40B4-BE49-F238E27FC236}">
+                <a16:creationId xmlns:a16="http://schemas.microsoft.com/office/drawing/2014/main" id="{4633F624-E58E-58C0-7412-5CF0EF0D452C}"/>
+              </a:ext>
+            </a:extLst>
+          </p:cNvPr>
+          <p:cNvSpPr>
+            <a:spLocks noGrp="1"/>
+          </p:cNvSpPr>
+          <p:nvPr>
+            <p:ph type="title"/>
+          </p:nvPr>
+        </p:nvSpPr>
+        <p:spPr/>
+        <p:txBody>
+          <a:bodyPr/>
+          <a:lstStyle/>
+          <a:p>
+            <a:r>
+              <a:rPr lang="en-FR" dirty="0"/>
+              <a:t>Appium on macOS for iOS</a:t>
+            </a:r>
+          </a:p>
+        </p:txBody>
+      </p:sp>
+      <p:sp>
+        <p:nvSpPr>
+          <p:cNvPr id="3" name="Content Placeholder 2">
+            <a:extLst>
+              <a:ext uri="{FF2B5EF4-FFF2-40B4-BE49-F238E27FC236}">
+                <a16:creationId xmlns:a16="http://schemas.microsoft.com/office/drawing/2014/main" id="{9921BF80-01DD-4F1B-C94D-24A74D816DC2}"/>
+              </a:ext>
+            </a:extLst>
+          </p:cNvPr>
+          <p:cNvSpPr>
+            <a:spLocks noGrp="1"/>
+          </p:cNvSpPr>
+          <p:nvPr>
+            <p:ph idx="1"/>
+          </p:nvPr>
+        </p:nvSpPr>
+        <p:spPr/>
+        <p:txBody>
+          <a:bodyPr/>
+          <a:lstStyle/>
+          <a:p>
+            <a:endParaRPr lang="en-FR" dirty="0"/>
+          </a:p>
+        </p:txBody>
+      </p:sp>
+    </p:spTree>
+    <p:extLst>
+      <p:ext uri="{BB962C8B-B14F-4D97-AF65-F5344CB8AC3E}">
+        <p14:creationId xmlns:p14="http://schemas.microsoft.com/office/powerpoint/2010/main" val="895585611"/>
       </p:ext>
     </p:extLst>
   </p:cSld>
@@ -7118,21 +8647,21 @@
 </file>
 
 <file path=customXml/item1.xml><?xml version="1.0" encoding="utf-8"?>
+<?mso-contentType ?>
+<FormTemplates xmlns="http://schemas.microsoft.com/sharepoint/v3/contenttype/forms">
+  <Display>DocumentLibraryForm</Display>
+  <Edit>DocumentLibraryForm</Edit>
+  <New>DocumentLibraryForm</New>
+</FormTemplates>
+</file>
+
+<file path=customXml/item2.xml><?xml version="1.0" encoding="utf-8"?>
 <p:properties xmlns:p="http://schemas.microsoft.com/office/2006/metadata/properties" xmlns:xsi="http://www.w3.org/2001/XMLSchema-instance" xmlns:pc="http://schemas.microsoft.com/office/infopath/2007/PartnerControls">
   <documentManagement>
     <Status xmlns="71af3243-3dd4-4a8d-8c0d-dd76da1f02a5">Not started</Status>
     <MediaServiceKeyPoints xmlns="71af3243-3dd4-4a8d-8c0d-dd76da1f02a5" xsi:nil="true"/>
   </documentManagement>
 </p:properties>
-</file>
-
-<file path=customXml/item2.xml><?xml version="1.0" encoding="utf-8"?>
-<?mso-contentType ?>
-<FormTemplates xmlns="http://schemas.microsoft.com/sharepoint/v3/contenttype/forms">
-  <Display>DocumentLibraryForm</Display>
-  <Edit>DocumentLibraryForm</Edit>
-  <New>DocumentLibraryForm</New>
-</FormTemplates>
 </file>
 
 <file path=customXml/item3.xml><?xml version="1.0" encoding="utf-8"?>
@@ -7357,6 +8886,14 @@
 </file>
 
 <file path=customXml/itemProps1.xml><?xml version="1.0" encoding="utf-8"?>
+<ds:datastoreItem xmlns:ds="http://schemas.openxmlformats.org/officeDocument/2006/customXml" ds:itemID="{AA3F7EDC-E5B4-4BBC-9D2A-CBE6D46C37AD}">
+  <ds:schemaRefs>
+    <ds:schemaRef ds:uri="http://schemas.microsoft.com/sharepoint/v3/contenttype/forms"/>
+  </ds:schemaRefs>
+</ds:datastoreItem>
+</file>
+
+<file path=customXml/itemProps2.xml><?xml version="1.0" encoding="utf-8"?>
 <ds:datastoreItem xmlns:ds="http://schemas.openxmlformats.org/officeDocument/2006/customXml" ds:itemID="{A03EEFF0-FB57-4CB4-8BFC-DF397689E2ED}">
   <ds:schemaRefs>
     <ds:schemaRef ds:uri="16c05727-aa75-4e4a-9b5f-8a80a1165891"/>
@@ -7369,14 +8906,6 @@
     <ds:schemaRef ds:uri="http://schemas.microsoft.com/office/infopath/2007/PartnerControls"/>
     <ds:schemaRef ds:uri="http://schemas.openxmlformats.org/package/2006/metadata/core-properties"/>
     <ds:schemaRef ds:uri="http://www.w3.org/XML/1998/namespace"/>
-  </ds:schemaRefs>
-</ds:datastoreItem>
-</file>
-
-<file path=customXml/itemProps2.xml><?xml version="1.0" encoding="utf-8"?>
-<ds:datastoreItem xmlns:ds="http://schemas.openxmlformats.org/officeDocument/2006/customXml" ds:itemID="{AA3F7EDC-E5B4-4BBC-9D2A-CBE6D46C37AD}">
-  <ds:schemaRefs>
-    <ds:schemaRef ds:uri="http://schemas.microsoft.com/sharepoint/v3/contenttype/forms"/>
   </ds:schemaRefs>
 </ds:datastoreItem>
 </file>

</xml_diff>